<commit_message>
Add new Excel workbook for Azure Migrate samples with multiple worksheets
</commit_message>
<xml_diff>
--- a/azure_arc_vsphere_jumpstart/VMware_to_Azure_Migration_Deck.pptx
+++ b/azure_arc_vsphere_jumpstart/VMware_to_Azure_Migration_Deck.pptx
@@ -5,25 +5,25 @@
     <p:sldMasterId id="2147483648" r:id="rId1"/>
   </p:sldMasterIdLst>
   <p:sldIdLst>
-    <p:sldId id="256" r:id="rId7"/>
-    <p:sldId id="257" r:id="rId8"/>
-    <p:sldId id="258" r:id="rId9"/>
-    <p:sldId id="259" r:id="rId10"/>
-    <p:sldId id="260" r:id="rId11"/>
-    <p:sldId id="261" r:id="rId12"/>
-    <p:sldId id="262" r:id="rId13"/>
-    <p:sldId id="263" r:id="rId14"/>
-    <p:sldId id="264" r:id="rId15"/>
-    <p:sldId id="265" r:id="rId16"/>
-    <p:sldId id="266" r:id="rId17"/>
-    <p:sldId id="267" r:id="rId18"/>
-    <p:sldId id="268" r:id="rId19"/>
-    <p:sldId id="269" r:id="rId20"/>
-    <p:sldId id="270" r:id="rId21"/>
-    <p:sldId id="271" r:id="rId22"/>
-    <p:sldId id="272" r:id="rId23"/>
+    <p:sldId id="256" r:id="rId2"/>
+    <p:sldId id="257" r:id="rId3"/>
+    <p:sldId id="258" r:id="rId4"/>
+    <p:sldId id="259" r:id="rId5"/>
+    <p:sldId id="260" r:id="rId6"/>
+    <p:sldId id="261" r:id="rId7"/>
+    <p:sldId id="262" r:id="rId8"/>
+    <p:sldId id="263" r:id="rId9"/>
+    <p:sldId id="264" r:id="rId10"/>
+    <p:sldId id="265" r:id="rId11"/>
+    <p:sldId id="266" r:id="rId12"/>
+    <p:sldId id="267" r:id="rId13"/>
+    <p:sldId id="268" r:id="rId14"/>
+    <p:sldId id="269" r:id="rId15"/>
+    <p:sldId id="270" r:id="rId16"/>
+    <p:sldId id="271" r:id="rId17"/>
+    <p:sldId id="272" r:id="rId18"/>
   </p:sldIdLst>
-  <p:sldSz cx="12191695" cy="6858000" type="screen4x3"/>
+  <p:sldSz cx="12192000" cy="6858000"/>
   <p:notesSz cx="6858000" cy="9144000"/>
   <p:defaultTextStyle>
     <a:defPPr>
@@ -120,6 +120,22 @@
       </a:defRPr>
     </a:lvl9pPr>
   </p:defaultTextStyle>
+  <p:extLst>
+    <p:ext uri="{EFAFB233-063F-42B5-8137-9DF3F51BA10A}">
+      <p15:sldGuideLst xmlns:p15="http://schemas.microsoft.com/office/powerpoint/2012/main">
+        <p15:guide id="1" orient="horz" pos="2160">
+          <p15:clr>
+            <a:srgbClr val="A4A3A4"/>
+          </p15:clr>
+        </p15:guide>
+        <p15:guide id="2" pos="2880">
+          <p15:clr>
+            <a:srgbClr val="A4A3A4"/>
+          </p15:clr>
+        </p15:guide>
+      </p15:sldGuideLst>
+    </p:ext>
+  </p:extLst>
 </p:presentation>
 </file>
 
@@ -161,10 +177,9 @@
           <a:lstStyle/>
           <a:p>
             <a:r>
-              <a:rPr lang="en-US" smtClean="0"/>
+              <a:rPr lang="en-US"/>
               <a:t>Click to edit Master title style</a:t>
             </a:r>
-            <a:endParaRPr lang="en-US"/>
           </a:p>
         </p:txBody>
       </p:sp>
@@ -280,10 +295,9 @@
           </a:lstStyle>
           <a:p>
             <a:r>
-              <a:rPr lang="en-US" smtClean="0"/>
+              <a:rPr lang="en-US"/>
               <a:t>Click to edit Master subtitle style</a:t>
             </a:r>
-            <a:endParaRPr lang="en-US"/>
           </a:p>
         </p:txBody>
       </p:sp>
@@ -304,7 +318,7 @@
           <a:p>
             <a:fld id="{5BCAD085-E8A6-8845-BD4E-CB4CCA059FC4}" type="datetimeFigureOut">
               <a:rPr lang="en-US" smtClean="0"/>
-              <a:t>1/27/13</a:t>
+              <a:t>4/7/2026</a:t>
             </a:fld>
             <a:endParaRPr lang="en-US"/>
           </a:p>
@@ -398,10 +412,9 @@
           <a:lstStyle/>
           <a:p>
             <a:r>
-              <a:rPr lang="en-US" smtClean="0"/>
+              <a:rPr lang="en-US"/>
               <a:t>Click to edit Master title style</a:t>
             </a:r>
-            <a:endParaRPr lang="en-US"/>
           </a:p>
         </p:txBody>
       </p:sp>
@@ -422,38 +435,37 @@
           <a:p>
             <a:pPr lvl="0"/>
             <a:r>
-              <a:rPr lang="en-US" smtClean="0"/>
+              <a:rPr lang="en-US"/>
               <a:t>Click to edit Master text styles</a:t>
             </a:r>
           </a:p>
           <a:p>
             <a:pPr lvl="1"/>
             <a:r>
-              <a:rPr lang="en-US" smtClean="0"/>
+              <a:rPr lang="en-US"/>
               <a:t>Second level</a:t>
             </a:r>
           </a:p>
           <a:p>
             <a:pPr lvl="2"/>
             <a:r>
-              <a:rPr lang="en-US" smtClean="0"/>
+              <a:rPr lang="en-US"/>
               <a:t>Third level</a:t>
             </a:r>
           </a:p>
           <a:p>
             <a:pPr lvl="3"/>
             <a:r>
-              <a:rPr lang="en-US" smtClean="0"/>
+              <a:rPr lang="en-US"/>
               <a:t>Fourth level</a:t>
             </a:r>
           </a:p>
           <a:p>
             <a:pPr lvl="4"/>
             <a:r>
-              <a:rPr lang="en-US" smtClean="0"/>
+              <a:rPr lang="en-US"/>
               <a:t>Fifth level</a:t>
             </a:r>
-            <a:endParaRPr lang="en-US"/>
           </a:p>
         </p:txBody>
       </p:sp>
@@ -474,7 +486,7 @@
           <a:p>
             <a:fld id="{5BCAD085-E8A6-8845-BD4E-CB4CCA059FC4}" type="datetimeFigureOut">
               <a:rPr lang="en-US" smtClean="0"/>
-              <a:t>1/27/13</a:t>
+              <a:t>4/7/2026</a:t>
             </a:fld>
             <a:endParaRPr lang="en-US"/>
           </a:p>
@@ -573,10 +585,9 @@
           <a:lstStyle/>
           <a:p>
             <a:r>
-              <a:rPr lang="en-US" smtClean="0"/>
+              <a:rPr lang="en-US"/>
               <a:t>Click to edit Master title style</a:t>
             </a:r>
-            <a:endParaRPr lang="en-US"/>
           </a:p>
         </p:txBody>
       </p:sp>
@@ -602,38 +613,37 @@
           <a:p>
             <a:pPr lvl="0"/>
             <a:r>
-              <a:rPr lang="en-US" smtClean="0"/>
+              <a:rPr lang="en-US"/>
               <a:t>Click to edit Master text styles</a:t>
             </a:r>
           </a:p>
           <a:p>
             <a:pPr lvl="1"/>
             <a:r>
-              <a:rPr lang="en-US" smtClean="0"/>
+              <a:rPr lang="en-US"/>
               <a:t>Second level</a:t>
             </a:r>
           </a:p>
           <a:p>
             <a:pPr lvl="2"/>
             <a:r>
-              <a:rPr lang="en-US" smtClean="0"/>
+              <a:rPr lang="en-US"/>
               <a:t>Third level</a:t>
             </a:r>
           </a:p>
           <a:p>
             <a:pPr lvl="3"/>
             <a:r>
-              <a:rPr lang="en-US" smtClean="0"/>
+              <a:rPr lang="en-US"/>
               <a:t>Fourth level</a:t>
             </a:r>
           </a:p>
           <a:p>
             <a:pPr lvl="4"/>
             <a:r>
-              <a:rPr lang="en-US" smtClean="0"/>
+              <a:rPr lang="en-US"/>
               <a:t>Fifth level</a:t>
             </a:r>
-            <a:endParaRPr lang="en-US"/>
           </a:p>
         </p:txBody>
       </p:sp>
@@ -654,7 +664,7 @@
           <a:p>
             <a:fld id="{5BCAD085-E8A6-8845-BD4E-CB4CCA059FC4}" type="datetimeFigureOut">
               <a:rPr lang="en-US" smtClean="0"/>
-              <a:t>1/27/13</a:t>
+              <a:t>4/7/2026</a:t>
             </a:fld>
             <a:endParaRPr lang="en-US"/>
           </a:p>
@@ -748,10 +758,9 @@
           <a:lstStyle/>
           <a:p>
             <a:r>
-              <a:rPr lang="en-US" smtClean="0"/>
+              <a:rPr lang="en-US"/>
               <a:t>Click to edit Master title style</a:t>
             </a:r>
-            <a:endParaRPr lang="en-US"/>
           </a:p>
         </p:txBody>
       </p:sp>
@@ -772,38 +781,37 @@
           <a:p>
             <a:pPr lvl="0"/>
             <a:r>
-              <a:rPr lang="en-US" smtClean="0"/>
+              <a:rPr lang="en-US"/>
               <a:t>Click to edit Master text styles</a:t>
             </a:r>
           </a:p>
           <a:p>
             <a:pPr lvl="1"/>
             <a:r>
-              <a:rPr lang="en-US" smtClean="0"/>
+              <a:rPr lang="en-US"/>
               <a:t>Second level</a:t>
             </a:r>
           </a:p>
           <a:p>
             <a:pPr lvl="2"/>
             <a:r>
-              <a:rPr lang="en-US" smtClean="0"/>
+              <a:rPr lang="en-US"/>
               <a:t>Third level</a:t>
             </a:r>
           </a:p>
           <a:p>
             <a:pPr lvl="3"/>
             <a:r>
-              <a:rPr lang="en-US" smtClean="0"/>
+              <a:rPr lang="en-US"/>
               <a:t>Fourth level</a:t>
             </a:r>
           </a:p>
           <a:p>
             <a:pPr lvl="4"/>
             <a:r>
-              <a:rPr lang="en-US" smtClean="0"/>
+              <a:rPr lang="en-US"/>
               <a:t>Fifth level</a:t>
             </a:r>
-            <a:endParaRPr lang="en-US"/>
           </a:p>
         </p:txBody>
       </p:sp>
@@ -824,7 +832,7 @@
           <a:p>
             <a:fld id="{5BCAD085-E8A6-8845-BD4E-CB4CCA059FC4}" type="datetimeFigureOut">
               <a:rPr lang="en-US" smtClean="0"/>
-              <a:t>1/27/13</a:t>
+              <a:t>4/7/2026</a:t>
             </a:fld>
             <a:endParaRPr lang="en-US"/>
           </a:p>
@@ -927,10 +935,9 @@
           </a:lstStyle>
           <a:p>
             <a:r>
-              <a:rPr lang="en-US" smtClean="0"/>
+              <a:rPr lang="en-US"/>
               <a:t>Click to edit Master title style</a:t>
             </a:r>
-            <a:endParaRPr lang="en-US"/>
           </a:p>
         </p:txBody>
       </p:sp>
@@ -1047,7 +1054,7 @@
           <a:p>
             <a:pPr lvl="0"/>
             <a:r>
-              <a:rPr lang="en-US" smtClean="0"/>
+              <a:rPr lang="en-US"/>
               <a:t>Click to edit Master text styles</a:t>
             </a:r>
           </a:p>
@@ -1070,7 +1077,7 @@
           <a:p>
             <a:fld id="{5BCAD085-E8A6-8845-BD4E-CB4CCA059FC4}" type="datetimeFigureOut">
               <a:rPr lang="en-US" smtClean="0"/>
-              <a:t>1/27/13</a:t>
+              <a:t>4/7/2026</a:t>
             </a:fld>
             <a:endParaRPr lang="en-US"/>
           </a:p>
@@ -1164,10 +1171,9 @@
           <a:lstStyle/>
           <a:p>
             <a:r>
-              <a:rPr lang="en-US" smtClean="0"/>
+              <a:rPr lang="en-US"/>
               <a:t>Click to edit Master title style</a:t>
             </a:r>
-            <a:endParaRPr lang="en-US"/>
           </a:p>
         </p:txBody>
       </p:sp>
@@ -1221,38 +1227,37 @@
           <a:p>
             <a:pPr lvl="0"/>
             <a:r>
-              <a:rPr lang="en-US" smtClean="0"/>
+              <a:rPr lang="en-US"/>
               <a:t>Click to edit Master text styles</a:t>
             </a:r>
           </a:p>
           <a:p>
             <a:pPr lvl="1"/>
             <a:r>
-              <a:rPr lang="en-US" smtClean="0"/>
+              <a:rPr lang="en-US"/>
               <a:t>Second level</a:t>
             </a:r>
           </a:p>
           <a:p>
             <a:pPr lvl="2"/>
             <a:r>
-              <a:rPr lang="en-US" smtClean="0"/>
+              <a:rPr lang="en-US"/>
               <a:t>Third level</a:t>
             </a:r>
           </a:p>
           <a:p>
             <a:pPr lvl="3"/>
             <a:r>
-              <a:rPr lang="en-US" smtClean="0"/>
+              <a:rPr lang="en-US"/>
               <a:t>Fourth level</a:t>
             </a:r>
           </a:p>
           <a:p>
             <a:pPr lvl="4"/>
             <a:r>
-              <a:rPr lang="en-US" smtClean="0"/>
+              <a:rPr lang="en-US"/>
               <a:t>Fifth level</a:t>
             </a:r>
-            <a:endParaRPr lang="en-US"/>
           </a:p>
         </p:txBody>
       </p:sp>
@@ -1306,38 +1311,37 @@
           <a:p>
             <a:pPr lvl="0"/>
             <a:r>
-              <a:rPr lang="en-US" smtClean="0"/>
+              <a:rPr lang="en-US"/>
               <a:t>Click to edit Master text styles</a:t>
             </a:r>
           </a:p>
           <a:p>
             <a:pPr lvl="1"/>
             <a:r>
-              <a:rPr lang="en-US" smtClean="0"/>
+              <a:rPr lang="en-US"/>
               <a:t>Second level</a:t>
             </a:r>
           </a:p>
           <a:p>
             <a:pPr lvl="2"/>
             <a:r>
-              <a:rPr lang="en-US" smtClean="0"/>
+              <a:rPr lang="en-US"/>
               <a:t>Third level</a:t>
             </a:r>
           </a:p>
           <a:p>
             <a:pPr lvl="3"/>
             <a:r>
-              <a:rPr lang="en-US" smtClean="0"/>
+              <a:rPr lang="en-US"/>
               <a:t>Fourth level</a:t>
             </a:r>
           </a:p>
           <a:p>
             <a:pPr lvl="4"/>
             <a:r>
-              <a:rPr lang="en-US" smtClean="0"/>
+              <a:rPr lang="en-US"/>
               <a:t>Fifth level</a:t>
             </a:r>
-            <a:endParaRPr lang="en-US"/>
           </a:p>
         </p:txBody>
       </p:sp>
@@ -1358,7 +1362,7 @@
           <a:p>
             <a:fld id="{5BCAD085-E8A6-8845-BD4E-CB4CCA059FC4}" type="datetimeFigureOut">
               <a:rPr lang="en-US" smtClean="0"/>
-              <a:t>1/27/13</a:t>
+              <a:t>4/7/2026</a:t>
             </a:fld>
             <a:endParaRPr lang="en-US"/>
           </a:p>
@@ -1456,10 +1460,9 @@
           </a:lstStyle>
           <a:p>
             <a:r>
-              <a:rPr lang="en-US" smtClean="0"/>
+              <a:rPr lang="en-US"/>
               <a:t>Click to edit Master title style</a:t>
             </a:r>
-            <a:endParaRPr lang="en-US"/>
           </a:p>
         </p:txBody>
       </p:sp>
@@ -1522,7 +1525,7 @@
           <a:p>
             <a:pPr lvl="0"/>
             <a:r>
-              <a:rPr lang="en-US" smtClean="0"/>
+              <a:rPr lang="en-US"/>
               <a:t>Click to edit Master text styles</a:t>
             </a:r>
           </a:p>
@@ -1578,38 +1581,37 @@
           <a:p>
             <a:pPr lvl="0"/>
             <a:r>
-              <a:rPr lang="en-US" smtClean="0"/>
+              <a:rPr lang="en-US"/>
               <a:t>Click to edit Master text styles</a:t>
             </a:r>
           </a:p>
           <a:p>
             <a:pPr lvl="1"/>
             <a:r>
-              <a:rPr lang="en-US" smtClean="0"/>
+              <a:rPr lang="en-US"/>
               <a:t>Second level</a:t>
             </a:r>
           </a:p>
           <a:p>
             <a:pPr lvl="2"/>
             <a:r>
-              <a:rPr lang="en-US" smtClean="0"/>
+              <a:rPr lang="en-US"/>
               <a:t>Third level</a:t>
             </a:r>
           </a:p>
           <a:p>
             <a:pPr lvl="3"/>
             <a:r>
-              <a:rPr lang="en-US" smtClean="0"/>
+              <a:rPr lang="en-US"/>
               <a:t>Fourth level</a:t>
             </a:r>
           </a:p>
           <a:p>
             <a:pPr lvl="4"/>
             <a:r>
-              <a:rPr lang="en-US" smtClean="0"/>
+              <a:rPr lang="en-US"/>
               <a:t>Fifth level</a:t>
             </a:r>
-            <a:endParaRPr lang="en-US"/>
           </a:p>
         </p:txBody>
       </p:sp>
@@ -1672,7 +1674,7 @@
           <a:p>
             <a:pPr lvl="0"/>
             <a:r>
-              <a:rPr lang="en-US" smtClean="0"/>
+              <a:rPr lang="en-US"/>
               <a:t>Click to edit Master text styles</a:t>
             </a:r>
           </a:p>
@@ -1728,38 +1730,37 @@
           <a:p>
             <a:pPr lvl="0"/>
             <a:r>
-              <a:rPr lang="en-US" smtClean="0"/>
+              <a:rPr lang="en-US"/>
               <a:t>Click to edit Master text styles</a:t>
             </a:r>
           </a:p>
           <a:p>
             <a:pPr lvl="1"/>
             <a:r>
-              <a:rPr lang="en-US" smtClean="0"/>
+              <a:rPr lang="en-US"/>
               <a:t>Second level</a:t>
             </a:r>
           </a:p>
           <a:p>
             <a:pPr lvl="2"/>
             <a:r>
-              <a:rPr lang="en-US" smtClean="0"/>
+              <a:rPr lang="en-US"/>
               <a:t>Third level</a:t>
             </a:r>
           </a:p>
           <a:p>
             <a:pPr lvl="3"/>
             <a:r>
-              <a:rPr lang="en-US" smtClean="0"/>
+              <a:rPr lang="en-US"/>
               <a:t>Fourth level</a:t>
             </a:r>
           </a:p>
           <a:p>
             <a:pPr lvl="4"/>
             <a:r>
-              <a:rPr lang="en-US" smtClean="0"/>
+              <a:rPr lang="en-US"/>
               <a:t>Fifth level</a:t>
             </a:r>
-            <a:endParaRPr lang="en-US"/>
           </a:p>
         </p:txBody>
       </p:sp>
@@ -1780,7 +1781,7 @@
           <a:p>
             <a:fld id="{5BCAD085-E8A6-8845-BD4E-CB4CCA059FC4}" type="datetimeFigureOut">
               <a:rPr lang="en-US" smtClean="0"/>
-              <a:t>1/27/13</a:t>
+              <a:t>4/7/2026</a:t>
             </a:fld>
             <a:endParaRPr lang="en-US"/>
           </a:p>
@@ -1874,10 +1875,9 @@
           <a:lstStyle/>
           <a:p>
             <a:r>
-              <a:rPr lang="en-US" smtClean="0"/>
+              <a:rPr lang="en-US"/>
               <a:t>Click to edit Master title style</a:t>
             </a:r>
-            <a:endParaRPr lang="en-US"/>
           </a:p>
         </p:txBody>
       </p:sp>
@@ -1898,7 +1898,7 @@
           <a:p>
             <a:fld id="{5BCAD085-E8A6-8845-BD4E-CB4CCA059FC4}" type="datetimeFigureOut">
               <a:rPr lang="en-US" smtClean="0"/>
-              <a:t>1/27/13</a:t>
+              <a:t>4/7/2026</a:t>
             </a:fld>
             <a:endParaRPr lang="en-US"/>
           </a:p>
@@ -1993,7 +1993,7 @@
           <a:p>
             <a:fld id="{5BCAD085-E8A6-8845-BD4E-CB4CCA059FC4}" type="datetimeFigureOut">
               <a:rPr lang="en-US" smtClean="0"/>
-              <a:t>1/27/13</a:t>
+              <a:t>4/7/2026</a:t>
             </a:fld>
             <a:endParaRPr lang="en-US"/>
           </a:p>
@@ -2096,10 +2096,9 @@
           </a:lstStyle>
           <a:p>
             <a:r>
-              <a:rPr lang="en-US" smtClean="0"/>
+              <a:rPr lang="en-US"/>
               <a:t>Click to edit Master title style</a:t>
             </a:r>
-            <a:endParaRPr lang="en-US"/>
           </a:p>
         </p:txBody>
       </p:sp>
@@ -2153,38 +2152,37 @@
           <a:p>
             <a:pPr lvl="0"/>
             <a:r>
-              <a:rPr lang="en-US" smtClean="0"/>
+              <a:rPr lang="en-US"/>
               <a:t>Click to edit Master text styles</a:t>
             </a:r>
           </a:p>
           <a:p>
             <a:pPr lvl="1"/>
             <a:r>
-              <a:rPr lang="en-US" smtClean="0"/>
+              <a:rPr lang="en-US"/>
               <a:t>Second level</a:t>
             </a:r>
           </a:p>
           <a:p>
             <a:pPr lvl="2"/>
             <a:r>
-              <a:rPr lang="en-US" smtClean="0"/>
+              <a:rPr lang="en-US"/>
               <a:t>Third level</a:t>
             </a:r>
           </a:p>
           <a:p>
             <a:pPr lvl="3"/>
             <a:r>
-              <a:rPr lang="en-US" smtClean="0"/>
+              <a:rPr lang="en-US"/>
               <a:t>Fourth level</a:t>
             </a:r>
           </a:p>
           <a:p>
             <a:pPr lvl="4"/>
             <a:r>
-              <a:rPr lang="en-US" smtClean="0"/>
+              <a:rPr lang="en-US"/>
               <a:t>Fifth level</a:t>
             </a:r>
-            <a:endParaRPr lang="en-US"/>
           </a:p>
         </p:txBody>
       </p:sp>
@@ -2247,7 +2245,7 @@
           <a:p>
             <a:pPr lvl="0"/>
             <a:r>
-              <a:rPr lang="en-US" smtClean="0"/>
+              <a:rPr lang="en-US"/>
               <a:t>Click to edit Master text styles</a:t>
             </a:r>
           </a:p>
@@ -2270,7 +2268,7 @@
           <a:p>
             <a:fld id="{5BCAD085-E8A6-8845-BD4E-CB4CCA059FC4}" type="datetimeFigureOut">
               <a:rPr lang="en-US" smtClean="0"/>
-              <a:t>1/27/13</a:t>
+              <a:t>4/7/2026</a:t>
             </a:fld>
             <a:endParaRPr lang="en-US"/>
           </a:p>
@@ -2373,10 +2371,9 @@
           </a:lstStyle>
           <a:p>
             <a:r>
-              <a:rPr lang="en-US" smtClean="0"/>
+              <a:rPr lang="en-US"/>
               <a:t>Click to edit Master title style</a:t>
             </a:r>
-            <a:endParaRPr lang="en-US"/>
           </a:p>
         </p:txBody>
       </p:sp>
@@ -2500,7 +2497,7 @@
           <a:p>
             <a:pPr lvl="0"/>
             <a:r>
-              <a:rPr lang="en-US" smtClean="0"/>
+              <a:rPr lang="en-US"/>
               <a:t>Click to edit Master text styles</a:t>
             </a:r>
           </a:p>
@@ -2523,7 +2520,7 @@
           <a:p>
             <a:fld id="{5BCAD085-E8A6-8845-BD4E-CB4CCA059FC4}" type="datetimeFigureOut">
               <a:rPr lang="en-US" smtClean="0"/>
-              <a:t>1/27/13</a:t>
+              <a:t>4/7/2026</a:t>
             </a:fld>
             <a:endParaRPr lang="en-US"/>
           </a:p>
@@ -2632,10 +2629,9 @@
           <a:lstStyle/>
           <a:p>
             <a:r>
-              <a:rPr lang="en-US" smtClean="0"/>
+              <a:rPr lang="en-US"/>
               <a:t>Click to edit Master title style</a:t>
             </a:r>
-            <a:endParaRPr lang="en-US"/>
           </a:p>
         </p:txBody>
       </p:sp>
@@ -2666,38 +2662,37 @@
           <a:p>
             <a:pPr lvl="0"/>
             <a:r>
-              <a:rPr lang="en-US" smtClean="0"/>
+              <a:rPr lang="en-US"/>
               <a:t>Click to edit Master text styles</a:t>
             </a:r>
           </a:p>
           <a:p>
             <a:pPr lvl="1"/>
             <a:r>
-              <a:rPr lang="en-US" smtClean="0"/>
+              <a:rPr lang="en-US"/>
               <a:t>Second level</a:t>
             </a:r>
           </a:p>
           <a:p>
             <a:pPr lvl="2"/>
             <a:r>
-              <a:rPr lang="en-US" smtClean="0"/>
+              <a:rPr lang="en-US"/>
               <a:t>Third level</a:t>
             </a:r>
           </a:p>
           <a:p>
             <a:pPr lvl="3"/>
             <a:r>
-              <a:rPr lang="en-US" smtClean="0"/>
+              <a:rPr lang="en-US"/>
               <a:t>Fourth level</a:t>
             </a:r>
           </a:p>
           <a:p>
             <a:pPr lvl="4"/>
             <a:r>
-              <a:rPr lang="en-US" smtClean="0"/>
+              <a:rPr lang="en-US"/>
               <a:t>Fifth level</a:t>
             </a:r>
-            <a:endParaRPr lang="en-US"/>
           </a:p>
         </p:txBody>
       </p:sp>
@@ -2736,7 +2731,7 @@
           <a:p>
             <a:fld id="{5BCAD085-E8A6-8845-BD4E-CB4CCA059FC4}" type="datetimeFigureOut">
               <a:rPr lang="en-US" smtClean="0"/>
-              <a:t>1/27/13</a:t>
+              <a:t>4/7/2026</a:t>
             </a:fld>
             <a:endParaRPr lang="en-US"/>
           </a:p>
@@ -3095,7 +3090,7 @@
 </file>
 
 <file path=ppt/slides/slide1.xml><?xml version="1.0" encoding="utf-8"?>
-<p:sld xmlns:a="http://schemas.openxmlformats.org/drawingml/2006/main" xmlns:p="http://schemas.openxmlformats.org/presentationml/2006/main" xmlns:r="http://schemas.openxmlformats.org/officeDocument/2006/relationships">
+<p:sld xmlns:a="http://schemas.openxmlformats.org/drawingml/2006/main" xmlns:r="http://schemas.openxmlformats.org/officeDocument/2006/relationships" xmlns:p="http://schemas.openxmlformats.org/presentationml/2006/main">
   <p:cSld>
     <p:bg>
       <p:bgPr>
@@ -3111,7 +3106,14 @@
         <p:cNvGrpSpPr/>
         <p:nvPr/>
       </p:nvGrpSpPr>
-      <p:grpSpPr/>
+      <p:grpSpPr>
+        <a:xfrm>
+          <a:off x="0" y="0"/>
+          <a:ext cx="0" cy="0"/>
+          <a:chOff x="0" y="0"/>
+          <a:chExt cx="0" cy="0"/>
+        </a:xfrm>
+      </p:grpSpPr>
       <p:sp>
         <p:nvSpPr>
           <p:cNvPr id="2" name="Rectangle 1"/>
@@ -3152,6 +3154,7 @@
           <a:lstStyle/>
           <a:p>
             <a:pPr algn="ctr"/>
+            <a:endParaRPr/>
           </a:p>
         </p:txBody>
       </p:sp>
@@ -3247,6 +3250,7 @@
           <a:lstStyle/>
           <a:p>
             <a:pPr algn="ctr"/>
+            <a:endParaRPr/>
           </a:p>
         </p:txBody>
       </p:sp>
@@ -3399,6 +3403,7 @@
           <a:lstStyle/>
           <a:p>
             <a:pPr algn="ctr"/>
+            <a:endParaRPr/>
           </a:p>
         </p:txBody>
       </p:sp>
@@ -3516,6 +3521,7 @@
           <a:lstStyle/>
           <a:p>
             <a:pPr algn="ctr"/>
+            <a:endParaRPr/>
           </a:p>
         </p:txBody>
       </p:sp>
@@ -3631,6 +3637,7 @@
           <a:lstStyle/>
           <a:p>
             <a:pPr algn="ctr"/>
+            <a:endParaRPr/>
           </a:p>
         </p:txBody>
       </p:sp>
@@ -3715,7 +3722,7 @@
 </file>
 
 <file path=ppt/slides/slide10.xml><?xml version="1.0" encoding="utf-8"?>
-<p:sld xmlns:a="http://schemas.openxmlformats.org/drawingml/2006/main" xmlns:p="http://schemas.openxmlformats.org/presentationml/2006/main" xmlns:r="http://schemas.openxmlformats.org/officeDocument/2006/relationships">
+<p:sld xmlns:a="http://schemas.openxmlformats.org/drawingml/2006/main" xmlns:r="http://schemas.openxmlformats.org/officeDocument/2006/relationships" xmlns:p="http://schemas.openxmlformats.org/presentationml/2006/main">
   <p:cSld>
     <p:bg>
       <p:bgPr>
@@ -3731,7 +3738,14 @@
         <p:cNvGrpSpPr/>
         <p:nvPr/>
       </p:nvGrpSpPr>
-      <p:grpSpPr/>
+      <p:grpSpPr>
+        <a:xfrm>
+          <a:off x="0" y="0"/>
+          <a:ext cx="0" cy="0"/>
+          <a:chOff x="0" y="0"/>
+          <a:chExt cx="0" cy="0"/>
+        </a:xfrm>
+      </p:grpSpPr>
       <p:sp>
         <p:nvSpPr>
           <p:cNvPr id="2" name="Rectangle 1"/>
@@ -3772,6 +3786,7 @@
           <a:lstStyle/>
           <a:p>
             <a:pPr algn="ctr"/>
+            <a:endParaRPr/>
           </a:p>
         </p:txBody>
       </p:sp>
@@ -3815,6 +3830,7 @@
           <a:lstStyle/>
           <a:p>
             <a:pPr algn="ctr"/>
+            <a:endParaRPr/>
           </a:p>
         </p:txBody>
       </p:sp>
@@ -3907,7 +3923,7 @@
           <a:noFill/>
         </p:spPr>
         <p:txBody>
-          <a:bodyPr wrap="square" lIns="76200" rIns="76200" tIns="50800" anchor="t">
+          <a:bodyPr wrap="square" lIns="76200" tIns="50800" rIns="76200" anchor="t">
             <a:spAutoFit/>
           </a:bodyPr>
           <a:lstStyle/>
@@ -4035,6 +4051,7 @@
           <a:lstStyle/>
           <a:p>
             <a:pPr algn="ctr"/>
+            <a:endParaRPr/>
           </a:p>
         </p:txBody>
       </p:sp>
@@ -4091,7 +4108,7 @@
           <a:noFill/>
         </p:spPr>
         <p:txBody>
-          <a:bodyPr wrap="square" lIns="76200" rIns="76200" tIns="50800" anchor="t">
+          <a:bodyPr wrap="square" lIns="76200" tIns="50800" rIns="76200" anchor="t">
             <a:spAutoFit/>
           </a:bodyPr>
           <a:lstStyle/>
@@ -4185,6 +4202,7 @@
           <a:lstStyle/>
           <a:p>
             <a:pPr algn="ctr"/>
+            <a:endParaRPr/>
           </a:p>
         </p:txBody>
       </p:sp>
@@ -4269,7 +4287,7 @@
 </file>
 
 <file path=ppt/slides/slide11.xml><?xml version="1.0" encoding="utf-8"?>
-<p:sld xmlns:a="http://schemas.openxmlformats.org/drawingml/2006/main" xmlns:p="http://schemas.openxmlformats.org/presentationml/2006/main" xmlns:r="http://schemas.openxmlformats.org/officeDocument/2006/relationships">
+<p:sld xmlns:a="http://schemas.openxmlformats.org/drawingml/2006/main" xmlns:r="http://schemas.openxmlformats.org/officeDocument/2006/relationships" xmlns:p="http://schemas.openxmlformats.org/presentationml/2006/main">
   <p:cSld>
     <p:bg>
       <p:bgPr>
@@ -4285,7 +4303,14 @@
         <p:cNvGrpSpPr/>
         <p:nvPr/>
       </p:nvGrpSpPr>
-      <p:grpSpPr/>
+      <p:grpSpPr>
+        <a:xfrm>
+          <a:off x="0" y="0"/>
+          <a:ext cx="0" cy="0"/>
+          <a:chOff x="0" y="0"/>
+          <a:chExt cx="0" cy="0"/>
+        </a:xfrm>
+      </p:grpSpPr>
       <p:sp>
         <p:nvSpPr>
           <p:cNvPr id="2" name="Rectangle 1"/>
@@ -4326,6 +4351,7 @@
           <a:lstStyle/>
           <a:p>
             <a:pPr algn="ctr"/>
+            <a:endParaRPr/>
           </a:p>
         </p:txBody>
       </p:sp>
@@ -4369,6 +4395,7 @@
           <a:lstStyle/>
           <a:p>
             <a:pPr algn="ctr"/>
+            <a:endParaRPr/>
           </a:p>
         </p:txBody>
       </p:sp>
@@ -4486,6 +4513,7 @@
           <a:lstStyle/>
           <a:p>
             <a:pPr algn="ctr"/>
+            <a:endParaRPr/>
           </a:p>
         </p:txBody>
       </p:sp>
@@ -4529,6 +4557,7 @@
           <a:lstStyle/>
           <a:p>
             <a:pPr algn="ctr"/>
+            <a:endParaRPr/>
           </a:p>
         </p:txBody>
       </p:sp>
@@ -4646,6 +4675,7 @@
           <a:lstStyle/>
           <a:p>
             <a:pPr algn="ctr"/>
+            <a:endParaRPr/>
           </a:p>
         </p:txBody>
       </p:sp>
@@ -4689,6 +4719,7 @@
           <a:lstStyle/>
           <a:p>
             <a:pPr algn="ctr"/>
+            <a:endParaRPr/>
           </a:p>
         </p:txBody>
       </p:sp>
@@ -4806,6 +4837,7 @@
           <a:lstStyle/>
           <a:p>
             <a:pPr algn="ctr"/>
+            <a:endParaRPr/>
           </a:p>
         </p:txBody>
       </p:sp>
@@ -4849,6 +4881,7 @@
           <a:lstStyle/>
           <a:p>
             <a:pPr algn="ctr"/>
+            <a:endParaRPr/>
           </a:p>
         </p:txBody>
       </p:sp>
@@ -4966,6 +4999,7 @@
           <a:lstStyle/>
           <a:p>
             <a:pPr algn="ctr"/>
+            <a:endParaRPr/>
           </a:p>
         </p:txBody>
       </p:sp>
@@ -5009,6 +5043,7 @@
           <a:lstStyle/>
           <a:p>
             <a:pPr algn="ctr"/>
+            <a:endParaRPr/>
           </a:p>
         </p:txBody>
       </p:sp>
@@ -5101,7 +5136,7 @@
           <a:noFill/>
         </p:spPr>
         <p:txBody>
-          <a:bodyPr wrap="square" lIns="76200" rIns="76200" tIns="50800" anchor="t">
+          <a:bodyPr wrap="square" lIns="76200" tIns="50800" rIns="76200" anchor="t">
             <a:spAutoFit/>
           </a:bodyPr>
           <a:lstStyle/>
@@ -5163,6 +5198,7 @@
           <a:lstStyle/>
           <a:p>
             <a:pPr algn="ctr"/>
+            <a:endParaRPr/>
           </a:p>
         </p:txBody>
       </p:sp>
@@ -5247,7 +5283,7 @@
 </file>
 
 <file path=ppt/slides/slide12.xml><?xml version="1.0" encoding="utf-8"?>
-<p:sld xmlns:a="http://schemas.openxmlformats.org/drawingml/2006/main" xmlns:p="http://schemas.openxmlformats.org/presentationml/2006/main" xmlns:r="http://schemas.openxmlformats.org/officeDocument/2006/relationships">
+<p:sld xmlns:a="http://schemas.openxmlformats.org/drawingml/2006/main" xmlns:r="http://schemas.openxmlformats.org/officeDocument/2006/relationships" xmlns:p="http://schemas.openxmlformats.org/presentationml/2006/main">
   <p:cSld>
     <p:bg>
       <p:bgPr>
@@ -5263,7 +5299,14 @@
         <p:cNvGrpSpPr/>
         <p:nvPr/>
       </p:nvGrpSpPr>
-      <p:grpSpPr/>
+      <p:grpSpPr>
+        <a:xfrm>
+          <a:off x="0" y="0"/>
+          <a:ext cx="0" cy="0"/>
+          <a:chOff x="0" y="0"/>
+          <a:chExt cx="0" cy="0"/>
+        </a:xfrm>
+      </p:grpSpPr>
       <p:sp>
         <p:nvSpPr>
           <p:cNvPr id="2" name="Rectangle 1"/>
@@ -5304,6 +5347,7 @@
           <a:lstStyle/>
           <a:p>
             <a:pPr algn="ctr"/>
+            <a:endParaRPr/>
           </a:p>
         </p:txBody>
       </p:sp>
@@ -5347,6 +5391,7 @@
           <a:lstStyle/>
           <a:p>
             <a:pPr algn="ctr"/>
+            <a:endParaRPr/>
           </a:p>
         </p:txBody>
       </p:sp>
@@ -5536,6 +5581,7 @@
           <a:lstStyle/>
           <a:p>
             <a:pPr algn="ctr"/>
+            <a:endParaRPr/>
           </a:p>
         </p:txBody>
       </p:sp>
@@ -5581,6 +5627,7 @@
           <a:lstStyle/>
           <a:p>
             <a:pPr algn="ctr"/>
+            <a:endParaRPr/>
           </a:p>
         </p:txBody>
       </p:sp>
@@ -5601,7 +5648,7 @@
           <a:noFill/>
         </p:spPr>
         <p:txBody>
-          <a:bodyPr wrap="square" lIns="76200" rIns="76200" tIns="50800" anchor="t">
+          <a:bodyPr wrap="square" lIns="76200" tIns="50800" rIns="76200" anchor="t">
             <a:spAutoFit/>
           </a:bodyPr>
           <a:lstStyle/>
@@ -5672,7 +5719,7 @@
           <a:noFill/>
         </p:spPr>
         <p:txBody>
-          <a:bodyPr wrap="square" lIns="76200" rIns="76200" tIns="50800" anchor="t">
+          <a:bodyPr wrap="square" lIns="76200" tIns="50800" rIns="76200" anchor="t">
             <a:spAutoFit/>
           </a:bodyPr>
           <a:lstStyle/>
@@ -5766,6 +5813,7 @@
           <a:lstStyle/>
           <a:p>
             <a:pPr algn="ctr"/>
+            <a:endParaRPr/>
           </a:p>
         </p:txBody>
       </p:sp>
@@ -5850,7 +5898,7 @@
 </file>
 
 <file path=ppt/slides/slide13.xml><?xml version="1.0" encoding="utf-8"?>
-<p:sld xmlns:a="http://schemas.openxmlformats.org/drawingml/2006/main" xmlns:p="http://schemas.openxmlformats.org/presentationml/2006/main" xmlns:r="http://schemas.openxmlformats.org/officeDocument/2006/relationships">
+<p:sld xmlns:a="http://schemas.openxmlformats.org/drawingml/2006/main" xmlns:r="http://schemas.openxmlformats.org/officeDocument/2006/relationships" xmlns:p="http://schemas.openxmlformats.org/presentationml/2006/main">
   <p:cSld>
     <p:bg>
       <p:bgPr>
@@ -5866,7 +5914,14 @@
         <p:cNvGrpSpPr/>
         <p:nvPr/>
       </p:nvGrpSpPr>
-      <p:grpSpPr/>
+      <p:grpSpPr>
+        <a:xfrm>
+          <a:off x="0" y="0"/>
+          <a:ext cx="0" cy="0"/>
+          <a:chOff x="0" y="0"/>
+          <a:chExt cx="0" cy="0"/>
+        </a:xfrm>
+      </p:grpSpPr>
       <p:sp>
         <p:nvSpPr>
           <p:cNvPr id="2" name="Rectangle 1"/>
@@ -5907,6 +5962,7 @@
           <a:lstStyle/>
           <a:p>
             <a:pPr algn="ctr"/>
+            <a:endParaRPr/>
           </a:p>
         </p:txBody>
       </p:sp>
@@ -5950,6 +6006,7 @@
           <a:lstStyle/>
           <a:p>
             <a:pPr algn="ctr"/>
+            <a:endParaRPr/>
           </a:p>
         </p:txBody>
       </p:sp>
@@ -6139,6 +6196,7 @@
           <a:lstStyle/>
           <a:p>
             <a:pPr algn="ctr"/>
+            <a:endParaRPr/>
           </a:p>
         </p:txBody>
       </p:sp>
@@ -6184,6 +6242,7 @@
           <a:lstStyle/>
           <a:p>
             <a:pPr algn="ctr"/>
+            <a:endParaRPr/>
           </a:p>
         </p:txBody>
       </p:sp>
@@ -6204,7 +6263,7 @@
           <a:noFill/>
         </p:spPr>
         <p:txBody>
-          <a:bodyPr wrap="square" lIns="76200" rIns="76200" tIns="50800" anchor="t">
+          <a:bodyPr wrap="square" lIns="76200" tIns="50800" rIns="76200" anchor="t">
             <a:spAutoFit/>
           </a:bodyPr>
           <a:lstStyle/>
@@ -6275,7 +6334,7 @@
           <a:noFill/>
         </p:spPr>
         <p:txBody>
-          <a:bodyPr wrap="square" lIns="76200" rIns="76200" tIns="50800" anchor="t">
+          <a:bodyPr wrap="square" lIns="76200" tIns="50800" rIns="76200" anchor="t">
             <a:spAutoFit/>
           </a:bodyPr>
           <a:lstStyle/>
@@ -6369,6 +6428,7 @@
           <a:lstStyle/>
           <a:p>
             <a:pPr algn="ctr"/>
+            <a:endParaRPr/>
           </a:p>
         </p:txBody>
       </p:sp>
@@ -6453,7 +6513,7 @@
 </file>
 
 <file path=ppt/slides/slide14.xml><?xml version="1.0" encoding="utf-8"?>
-<p:sld xmlns:a="http://schemas.openxmlformats.org/drawingml/2006/main" xmlns:p="http://schemas.openxmlformats.org/presentationml/2006/main" xmlns:r="http://schemas.openxmlformats.org/officeDocument/2006/relationships">
+<p:sld xmlns:a="http://schemas.openxmlformats.org/drawingml/2006/main" xmlns:r="http://schemas.openxmlformats.org/officeDocument/2006/relationships" xmlns:p="http://schemas.openxmlformats.org/presentationml/2006/main">
   <p:cSld>
     <p:bg>
       <p:bgPr>
@@ -6469,7 +6529,14 @@
         <p:cNvGrpSpPr/>
         <p:nvPr/>
       </p:nvGrpSpPr>
-      <p:grpSpPr/>
+      <p:grpSpPr>
+        <a:xfrm>
+          <a:off x="0" y="0"/>
+          <a:ext cx="0" cy="0"/>
+          <a:chOff x="0" y="0"/>
+          <a:chExt cx="0" cy="0"/>
+        </a:xfrm>
+      </p:grpSpPr>
       <p:sp>
         <p:nvSpPr>
           <p:cNvPr id="2" name="Rectangle 1"/>
@@ -6510,6 +6577,7 @@
           <a:lstStyle/>
           <a:p>
             <a:pPr algn="ctr"/>
+            <a:endParaRPr/>
           </a:p>
         </p:txBody>
       </p:sp>
@@ -6553,6 +6621,7 @@
           <a:lstStyle/>
           <a:p>
             <a:pPr algn="ctr"/>
+            <a:endParaRPr/>
           </a:p>
         </p:txBody>
       </p:sp>
@@ -6670,6 +6739,7 @@
           <a:lstStyle/>
           <a:p>
             <a:pPr algn="ctr"/>
+            <a:endParaRPr/>
           </a:p>
         </p:txBody>
       </p:sp>
@@ -6713,6 +6783,7 @@
           <a:lstStyle/>
           <a:p>
             <a:pPr algn="ctr"/>
+            <a:endParaRPr/>
           </a:p>
         </p:txBody>
       </p:sp>
@@ -6830,6 +6901,7 @@
           <a:lstStyle/>
           <a:p>
             <a:pPr algn="ctr"/>
+            <a:endParaRPr/>
           </a:p>
         </p:txBody>
       </p:sp>
@@ -6873,6 +6945,7 @@
           <a:lstStyle/>
           <a:p>
             <a:pPr algn="ctr"/>
+            <a:endParaRPr/>
           </a:p>
         </p:txBody>
       </p:sp>
@@ -6990,6 +7063,7 @@
           <a:lstStyle/>
           <a:p>
             <a:pPr algn="ctr"/>
+            <a:endParaRPr/>
           </a:p>
         </p:txBody>
       </p:sp>
@@ -7033,6 +7107,7 @@
           <a:lstStyle/>
           <a:p>
             <a:pPr algn="ctr"/>
+            <a:endParaRPr/>
           </a:p>
         </p:txBody>
       </p:sp>
@@ -7080,8 +7155,8 @@
         </p:nvSpPr>
         <p:spPr>
           <a:xfrm>
-            <a:off x="6419088" y="2423160"/>
-            <a:ext cx="2240280" cy="502920"/>
+            <a:off x="6355080" y="2351678"/>
+            <a:ext cx="2542032" cy="600164"/>
           </a:xfrm>
           <a:prstGeom prst="rect">
             <a:avLst/>
@@ -7103,6 +7178,7 @@
               </a:defRPr>
             </a:pPr>
             <a:r>
+              <a:rPr dirty="0"/>
               <a:t>Use Extended Security Updates in Azure for older Windows Server and SQL Server estates when required.</a:t>
             </a:r>
           </a:p>
@@ -7150,6 +7226,7 @@
           <a:lstStyle/>
           <a:p>
             <a:pPr algn="ctr"/>
+            <a:endParaRPr/>
           </a:p>
         </p:txBody>
       </p:sp>
@@ -7193,6 +7270,7 @@
           <a:lstStyle/>
           <a:p>
             <a:pPr algn="ctr"/>
+            <a:endParaRPr/>
           </a:p>
         </p:txBody>
       </p:sp>
@@ -7240,8 +7318,8 @@
         </p:nvSpPr>
         <p:spPr>
           <a:xfrm>
-            <a:off x="9162288" y="2423160"/>
-            <a:ext cx="2240280" cy="502920"/>
+            <a:off x="9098280" y="2340864"/>
+            <a:ext cx="2377440" cy="600164"/>
           </a:xfrm>
           <a:prstGeom prst="rect">
             <a:avLst/>
@@ -7263,6 +7341,7 @@
               </a:defRPr>
             </a:pPr>
             <a:r>
+              <a:rPr dirty="0"/>
               <a:t>Use Azure Migrate assessment data to resize compute based on actual CPU, memory, and storage usage.</a:t>
             </a:r>
           </a:p>
@@ -7310,6 +7389,7 @@
           <a:lstStyle/>
           <a:p>
             <a:pPr algn="ctr"/>
+            <a:endParaRPr/>
           </a:p>
         </p:txBody>
       </p:sp>
@@ -7366,7 +7446,7 @@
           <a:noFill/>
         </p:spPr>
         <p:txBody>
-          <a:bodyPr wrap="square" lIns="76200" rIns="76200" tIns="50800" anchor="t">
+          <a:bodyPr wrap="square" lIns="76200" tIns="50800" rIns="76200" anchor="t">
             <a:spAutoFit/>
           </a:bodyPr>
           <a:lstStyle/>
@@ -7457,7 +7537,7 @@
           <a:noFill/>
         </p:spPr>
         <p:txBody>
-          <a:bodyPr wrap="square" lIns="76200" rIns="76200" tIns="50800" anchor="t">
+          <a:bodyPr wrap="square" lIns="76200" tIns="50800" rIns="76200" anchor="t">
             <a:spAutoFit/>
           </a:bodyPr>
           <a:lstStyle/>
@@ -7535,6 +7615,7 @@
           <a:lstStyle/>
           <a:p>
             <a:pPr algn="ctr"/>
+            <a:endParaRPr/>
           </a:p>
         </p:txBody>
       </p:sp>
@@ -7619,7 +7700,7 @@
 </file>
 
 <file path=ppt/slides/slide15.xml><?xml version="1.0" encoding="utf-8"?>
-<p:sld xmlns:a="http://schemas.openxmlformats.org/drawingml/2006/main" xmlns:p="http://schemas.openxmlformats.org/presentationml/2006/main" xmlns:r="http://schemas.openxmlformats.org/officeDocument/2006/relationships">
+<p:sld xmlns:a="http://schemas.openxmlformats.org/drawingml/2006/main" xmlns:r="http://schemas.openxmlformats.org/officeDocument/2006/relationships" xmlns:p="http://schemas.openxmlformats.org/presentationml/2006/main">
   <p:cSld>
     <p:bg>
       <p:bgPr>
@@ -7635,7 +7716,14 @@
         <p:cNvGrpSpPr/>
         <p:nvPr/>
       </p:nvGrpSpPr>
-      <p:grpSpPr/>
+      <p:grpSpPr>
+        <a:xfrm>
+          <a:off x="0" y="0"/>
+          <a:ext cx="0" cy="0"/>
+          <a:chOff x="0" y="0"/>
+          <a:chExt cx="0" cy="0"/>
+        </a:xfrm>
+      </p:grpSpPr>
       <p:sp>
         <p:nvSpPr>
           <p:cNvPr id="2" name="Rectangle 1"/>
@@ -7676,6 +7764,7 @@
           <a:lstStyle/>
           <a:p>
             <a:pPr algn="ctr"/>
+            <a:endParaRPr/>
           </a:p>
         </p:txBody>
       </p:sp>
@@ -7719,6 +7808,7 @@
           <a:lstStyle/>
           <a:p>
             <a:pPr algn="ctr"/>
+            <a:endParaRPr/>
           </a:p>
         </p:txBody>
       </p:sp>
@@ -7908,6 +7998,7 @@
           <a:lstStyle/>
           <a:p>
             <a:pPr algn="ctr"/>
+            <a:endParaRPr/>
           </a:p>
         </p:txBody>
       </p:sp>
@@ -7953,6 +8044,7 @@
           <a:lstStyle/>
           <a:p>
             <a:pPr algn="ctr"/>
+            <a:endParaRPr/>
           </a:p>
         </p:txBody>
       </p:sp>
@@ -7973,7 +8065,7 @@
           <a:noFill/>
         </p:spPr>
         <p:txBody>
-          <a:bodyPr wrap="square" lIns="76200" rIns="76200" tIns="50800" anchor="t">
+          <a:bodyPr wrap="square" lIns="76200" tIns="50800" rIns="76200" anchor="t">
             <a:spAutoFit/>
           </a:bodyPr>
           <a:lstStyle/>
@@ -8044,7 +8136,7 @@
           <a:noFill/>
         </p:spPr>
         <p:txBody>
-          <a:bodyPr wrap="square" lIns="76200" rIns="76200" tIns="50800" anchor="t">
+          <a:bodyPr wrap="square" lIns="76200" tIns="50800" rIns="76200" anchor="t">
             <a:spAutoFit/>
           </a:bodyPr>
           <a:lstStyle/>
@@ -8138,6 +8230,7 @@
           <a:lstStyle/>
           <a:p>
             <a:pPr algn="ctr"/>
+            <a:endParaRPr/>
           </a:p>
         </p:txBody>
       </p:sp>
@@ -8222,7 +8315,7 @@
 </file>
 
 <file path=ppt/slides/slide16.xml><?xml version="1.0" encoding="utf-8"?>
-<p:sld xmlns:a="http://schemas.openxmlformats.org/drawingml/2006/main" xmlns:p="http://schemas.openxmlformats.org/presentationml/2006/main" xmlns:r="http://schemas.openxmlformats.org/officeDocument/2006/relationships">
+<p:sld xmlns:a="http://schemas.openxmlformats.org/drawingml/2006/main" xmlns:r="http://schemas.openxmlformats.org/officeDocument/2006/relationships" xmlns:p="http://schemas.openxmlformats.org/presentationml/2006/main">
   <p:cSld>
     <p:bg>
       <p:bgPr>
@@ -8238,7 +8331,14 @@
         <p:cNvGrpSpPr/>
         <p:nvPr/>
       </p:nvGrpSpPr>
-      <p:grpSpPr/>
+      <p:grpSpPr>
+        <a:xfrm>
+          <a:off x="0" y="0"/>
+          <a:ext cx="0" cy="0"/>
+          <a:chOff x="0" y="0"/>
+          <a:chExt cx="0" cy="0"/>
+        </a:xfrm>
+      </p:grpSpPr>
       <p:sp>
         <p:nvSpPr>
           <p:cNvPr id="2" name="Rectangle 1"/>
@@ -8279,6 +8379,7 @@
           <a:lstStyle/>
           <a:p>
             <a:pPr algn="ctr"/>
+            <a:endParaRPr/>
           </a:p>
         </p:txBody>
       </p:sp>
@@ -8322,6 +8423,7 @@
           <a:lstStyle/>
           <a:p>
             <a:pPr algn="ctr"/>
+            <a:endParaRPr/>
           </a:p>
         </p:txBody>
       </p:sp>
@@ -8439,6 +8541,7 @@
           <a:lstStyle/>
           <a:p>
             <a:pPr algn="ctr"/>
+            <a:endParaRPr/>
           </a:p>
         </p:txBody>
       </p:sp>
@@ -8482,6 +8585,7 @@
           <a:lstStyle/>
           <a:p>
             <a:pPr algn="ctr"/>
+            <a:endParaRPr/>
           </a:p>
         </p:txBody>
       </p:sp>
@@ -8538,7 +8642,7 @@
           <a:noFill/>
         </p:spPr>
         <p:txBody>
-          <a:bodyPr wrap="square" lIns="76200" rIns="76200" tIns="50800" anchor="t">
+          <a:bodyPr wrap="square" lIns="76200" tIns="50800" rIns="76200" anchor="t">
             <a:spAutoFit/>
           </a:bodyPr>
           <a:lstStyle/>
@@ -8618,6 +8722,7 @@
           <a:lstStyle/>
           <a:p>
             <a:pPr algn="ctr"/>
+            <a:endParaRPr/>
           </a:p>
         </p:txBody>
       </p:sp>
@@ -8661,6 +8766,7 @@
           <a:lstStyle/>
           <a:p>
             <a:pPr algn="ctr"/>
+            <a:endParaRPr/>
           </a:p>
         </p:txBody>
       </p:sp>
@@ -8717,7 +8823,7 @@
           <a:noFill/>
         </p:spPr>
         <p:txBody>
-          <a:bodyPr wrap="square" lIns="76200" rIns="76200" tIns="50800" anchor="t">
+          <a:bodyPr wrap="square" lIns="76200" tIns="50800" rIns="76200" anchor="t">
             <a:spAutoFit/>
           </a:bodyPr>
           <a:lstStyle/>
@@ -8797,6 +8903,7 @@
           <a:lstStyle/>
           <a:p>
             <a:pPr algn="ctr"/>
+            <a:endParaRPr/>
           </a:p>
         </p:txBody>
       </p:sp>
@@ -8840,6 +8947,7 @@
           <a:lstStyle/>
           <a:p>
             <a:pPr algn="ctr"/>
+            <a:endParaRPr/>
           </a:p>
         </p:txBody>
       </p:sp>
@@ -8896,7 +9004,7 @@
           <a:noFill/>
         </p:spPr>
         <p:txBody>
-          <a:bodyPr wrap="square" lIns="76200" rIns="76200" tIns="50800" anchor="t">
+          <a:bodyPr wrap="square" lIns="76200" tIns="50800" rIns="76200" anchor="t">
             <a:spAutoFit/>
           </a:bodyPr>
           <a:lstStyle/>
@@ -8974,6 +9082,7 @@
           <a:lstStyle/>
           <a:p>
             <a:pPr algn="ctr"/>
+            <a:endParaRPr/>
           </a:p>
         </p:txBody>
       </p:sp>
@@ -9058,7 +9167,7 @@
 </file>
 
 <file path=ppt/slides/slide17.xml><?xml version="1.0" encoding="utf-8"?>
-<p:sld xmlns:a="http://schemas.openxmlformats.org/drawingml/2006/main" xmlns:p="http://schemas.openxmlformats.org/presentationml/2006/main" xmlns:r="http://schemas.openxmlformats.org/officeDocument/2006/relationships">
+<p:sld xmlns:a="http://schemas.openxmlformats.org/drawingml/2006/main" xmlns:r="http://schemas.openxmlformats.org/officeDocument/2006/relationships" xmlns:p="http://schemas.openxmlformats.org/presentationml/2006/main">
   <p:cSld>
     <p:bg>
       <p:bgPr>
@@ -9074,7 +9183,14 @@
         <p:cNvGrpSpPr/>
         <p:nvPr/>
       </p:nvGrpSpPr>
-      <p:grpSpPr/>
+      <p:grpSpPr>
+        <a:xfrm>
+          <a:off x="0" y="0"/>
+          <a:ext cx="0" cy="0"/>
+          <a:chOff x="0" y="0"/>
+          <a:chExt cx="0" cy="0"/>
+        </a:xfrm>
+      </p:grpSpPr>
       <p:sp>
         <p:nvSpPr>
           <p:cNvPr id="2" name="Rectangle 1"/>
@@ -9115,6 +9231,7 @@
           <a:lstStyle/>
           <a:p>
             <a:pPr algn="ctr"/>
+            <a:endParaRPr/>
           </a:p>
         </p:txBody>
       </p:sp>
@@ -9158,6 +9275,7 @@
           <a:lstStyle/>
           <a:p>
             <a:pPr algn="ctr"/>
+            <a:endParaRPr/>
           </a:p>
         </p:txBody>
       </p:sp>
@@ -9214,7 +9332,7 @@
           <a:noFill/>
         </p:spPr>
         <p:txBody>
-          <a:bodyPr wrap="square" lIns="76200" rIns="76200" tIns="50800" anchor="t">
+          <a:bodyPr wrap="square" lIns="76200" tIns="50800" rIns="76200" anchor="t">
             <a:spAutoFit/>
           </a:bodyPr>
           <a:lstStyle/>
@@ -9388,6 +9506,7 @@
           <a:lstStyle/>
           <a:p>
             <a:pPr algn="ctr"/>
+            <a:endParaRPr/>
           </a:p>
         </p:txBody>
       </p:sp>
@@ -9472,7 +9591,7 @@
 </file>
 
 <file path=ppt/slides/slide2.xml><?xml version="1.0" encoding="utf-8"?>
-<p:sld xmlns:a="http://schemas.openxmlformats.org/drawingml/2006/main" xmlns:p="http://schemas.openxmlformats.org/presentationml/2006/main" xmlns:r="http://schemas.openxmlformats.org/officeDocument/2006/relationships">
+<p:sld xmlns:a="http://schemas.openxmlformats.org/drawingml/2006/main" xmlns:r="http://schemas.openxmlformats.org/officeDocument/2006/relationships" xmlns:p="http://schemas.openxmlformats.org/presentationml/2006/main">
   <p:cSld>
     <p:bg>
       <p:bgPr>
@@ -9488,7 +9607,14 @@
         <p:cNvGrpSpPr/>
         <p:nvPr/>
       </p:nvGrpSpPr>
-      <p:grpSpPr/>
+      <p:grpSpPr>
+        <a:xfrm>
+          <a:off x="0" y="0"/>
+          <a:ext cx="0" cy="0"/>
+          <a:chOff x="0" y="0"/>
+          <a:chExt cx="0" cy="0"/>
+        </a:xfrm>
+      </p:grpSpPr>
       <p:sp>
         <p:nvSpPr>
           <p:cNvPr id="2" name="Rectangle 1"/>
@@ -9529,6 +9655,7 @@
           <a:lstStyle/>
           <a:p>
             <a:pPr algn="ctr"/>
+            <a:endParaRPr/>
           </a:p>
         </p:txBody>
       </p:sp>
@@ -9572,6 +9699,7 @@
           <a:lstStyle/>
           <a:p>
             <a:pPr algn="ctr"/>
+            <a:endParaRPr/>
           </a:p>
         </p:txBody>
       </p:sp>
@@ -9689,6 +9817,7 @@
           <a:lstStyle/>
           <a:p>
             <a:pPr algn="ctr"/>
+            <a:endParaRPr/>
           </a:p>
         </p:txBody>
       </p:sp>
@@ -9806,6 +9935,7 @@
           <a:lstStyle/>
           <a:p>
             <a:pPr algn="ctr"/>
+            <a:endParaRPr/>
           </a:p>
         </p:txBody>
       </p:sp>
@@ -9923,6 +10053,7 @@
           <a:lstStyle/>
           <a:p>
             <a:pPr algn="ctr"/>
+            <a:endParaRPr/>
           </a:p>
         </p:txBody>
       </p:sp>
@@ -10015,7 +10146,7 @@
           <a:noFill/>
         </p:spPr>
         <p:txBody>
-          <a:bodyPr wrap="square" lIns="76200" rIns="76200" tIns="50800" anchor="t">
+          <a:bodyPr wrap="square" lIns="76200" tIns="50800" rIns="76200" anchor="t">
             <a:spAutoFit/>
           </a:bodyPr>
           <a:lstStyle/>
@@ -10109,6 +10240,7 @@
           <a:lstStyle/>
           <a:p>
             <a:pPr algn="ctr"/>
+            <a:endParaRPr/>
           </a:p>
         </p:txBody>
       </p:sp>
@@ -10193,7 +10325,7 @@
 </file>
 
 <file path=ppt/slides/slide3.xml><?xml version="1.0" encoding="utf-8"?>
-<p:sld xmlns:a="http://schemas.openxmlformats.org/drawingml/2006/main" xmlns:p="http://schemas.openxmlformats.org/presentationml/2006/main" xmlns:r="http://schemas.openxmlformats.org/officeDocument/2006/relationships">
+<p:sld xmlns:a="http://schemas.openxmlformats.org/drawingml/2006/main" xmlns:r="http://schemas.openxmlformats.org/officeDocument/2006/relationships" xmlns:p="http://schemas.openxmlformats.org/presentationml/2006/main">
   <p:cSld>
     <p:bg>
       <p:bgPr>
@@ -10209,7 +10341,14 @@
         <p:cNvGrpSpPr/>
         <p:nvPr/>
       </p:nvGrpSpPr>
-      <p:grpSpPr/>
+      <p:grpSpPr>
+        <a:xfrm>
+          <a:off x="0" y="0"/>
+          <a:ext cx="0" cy="0"/>
+          <a:chOff x="0" y="0"/>
+          <a:chExt cx="0" cy="0"/>
+        </a:xfrm>
+      </p:grpSpPr>
       <p:sp>
         <p:nvSpPr>
           <p:cNvPr id="2" name="Rectangle 1"/>
@@ -10250,6 +10389,7 @@
           <a:lstStyle/>
           <a:p>
             <a:pPr algn="ctr"/>
+            <a:endParaRPr/>
           </a:p>
         </p:txBody>
       </p:sp>
@@ -10293,6 +10433,7 @@
           <a:lstStyle/>
           <a:p>
             <a:pPr algn="ctr"/>
+            <a:endParaRPr/>
           </a:p>
         </p:txBody>
       </p:sp>
@@ -10410,6 +10551,7 @@
           <a:lstStyle/>
           <a:p>
             <a:pPr algn="ctr"/>
+            <a:endParaRPr/>
           </a:p>
         </p:txBody>
       </p:sp>
@@ -10453,6 +10595,7 @@
           <a:lstStyle/>
           <a:p>
             <a:pPr algn="ctr"/>
+            <a:endParaRPr/>
           </a:p>
         </p:txBody>
       </p:sp>
@@ -10570,6 +10713,7 @@
           <a:lstStyle/>
           <a:p>
             <a:pPr algn="ctr"/>
+            <a:endParaRPr/>
           </a:p>
         </p:txBody>
       </p:sp>
@@ -10613,6 +10757,7 @@
           <a:lstStyle/>
           <a:p>
             <a:pPr algn="ctr"/>
+            <a:endParaRPr/>
           </a:p>
         </p:txBody>
       </p:sp>
@@ -10730,6 +10875,7 @@
           <a:lstStyle/>
           <a:p>
             <a:pPr algn="ctr"/>
+            <a:endParaRPr/>
           </a:p>
         </p:txBody>
       </p:sp>
@@ -10773,6 +10919,7 @@
           <a:lstStyle/>
           <a:p>
             <a:pPr algn="ctr"/>
+            <a:endParaRPr/>
           </a:p>
         </p:txBody>
       </p:sp>
@@ -10890,6 +11037,7 @@
           <a:lstStyle/>
           <a:p>
             <a:pPr algn="ctr"/>
+            <a:endParaRPr/>
           </a:p>
         </p:txBody>
       </p:sp>
@@ -10933,6 +11081,7 @@
           <a:lstStyle/>
           <a:p>
             <a:pPr algn="ctr"/>
+            <a:endParaRPr/>
           </a:p>
         </p:txBody>
       </p:sp>
@@ -11025,7 +11174,7 @@
           <a:noFill/>
         </p:spPr>
         <p:txBody>
-          <a:bodyPr wrap="square" lIns="76200" rIns="76200" tIns="50800" anchor="t">
+          <a:bodyPr wrap="square" lIns="76200" tIns="50800" rIns="76200" anchor="t">
             <a:spAutoFit/>
           </a:bodyPr>
           <a:lstStyle/>
@@ -11119,6 +11268,7 @@
           <a:lstStyle/>
           <a:p>
             <a:pPr algn="ctr"/>
+            <a:endParaRPr/>
           </a:p>
         </p:txBody>
       </p:sp>
@@ -11203,7 +11353,7 @@
 </file>
 
 <file path=ppt/slides/slide4.xml><?xml version="1.0" encoding="utf-8"?>
-<p:sld xmlns:a="http://schemas.openxmlformats.org/drawingml/2006/main" xmlns:p="http://schemas.openxmlformats.org/presentationml/2006/main" xmlns:r="http://schemas.openxmlformats.org/officeDocument/2006/relationships">
+<p:sld xmlns:a="http://schemas.openxmlformats.org/drawingml/2006/main" xmlns:r="http://schemas.openxmlformats.org/officeDocument/2006/relationships" xmlns:p="http://schemas.openxmlformats.org/presentationml/2006/main">
   <p:cSld>
     <p:bg>
       <p:bgPr>
@@ -11219,7 +11369,14 @@
         <p:cNvGrpSpPr/>
         <p:nvPr/>
       </p:nvGrpSpPr>
-      <p:grpSpPr/>
+      <p:grpSpPr>
+        <a:xfrm>
+          <a:off x="0" y="0"/>
+          <a:ext cx="0" cy="0"/>
+          <a:chOff x="0" y="0"/>
+          <a:chExt cx="0" cy="0"/>
+        </a:xfrm>
+      </p:grpSpPr>
       <p:sp>
         <p:nvSpPr>
           <p:cNvPr id="2" name="Rectangle 1"/>
@@ -11260,6 +11417,7 @@
           <a:lstStyle/>
           <a:p>
             <a:pPr algn="ctr"/>
+            <a:endParaRPr/>
           </a:p>
         </p:txBody>
       </p:sp>
@@ -11375,6 +11533,7 @@
           <a:lstStyle/>
           <a:p>
             <a:pPr algn="ctr"/>
+            <a:endParaRPr/>
           </a:p>
         </p:txBody>
       </p:sp>
@@ -11459,7 +11618,7 @@
 </file>
 
 <file path=ppt/slides/slide5.xml><?xml version="1.0" encoding="utf-8"?>
-<p:sld xmlns:a="http://schemas.openxmlformats.org/drawingml/2006/main" xmlns:p="http://schemas.openxmlformats.org/presentationml/2006/main" xmlns:r="http://schemas.openxmlformats.org/officeDocument/2006/relationships">
+<p:sld xmlns:a="http://schemas.openxmlformats.org/drawingml/2006/main" xmlns:r="http://schemas.openxmlformats.org/officeDocument/2006/relationships" xmlns:p="http://schemas.openxmlformats.org/presentationml/2006/main">
   <p:cSld>
     <p:bg>
       <p:bgPr>
@@ -11475,7 +11634,14 @@
         <p:cNvGrpSpPr/>
         <p:nvPr/>
       </p:nvGrpSpPr>
-      <p:grpSpPr/>
+      <p:grpSpPr>
+        <a:xfrm>
+          <a:off x="0" y="0"/>
+          <a:ext cx="0" cy="0"/>
+          <a:chOff x="0" y="0"/>
+          <a:chExt cx="0" cy="0"/>
+        </a:xfrm>
+      </p:grpSpPr>
       <p:sp>
         <p:nvSpPr>
           <p:cNvPr id="2" name="Rectangle 1"/>
@@ -11516,6 +11682,7 @@
           <a:lstStyle/>
           <a:p>
             <a:pPr algn="ctr"/>
+            <a:endParaRPr/>
           </a:p>
         </p:txBody>
       </p:sp>
@@ -11559,6 +11726,7 @@
           <a:lstStyle/>
           <a:p>
             <a:pPr algn="ctr"/>
+            <a:endParaRPr/>
           </a:p>
         </p:txBody>
       </p:sp>
@@ -11748,6 +11916,7 @@
           <a:lstStyle/>
           <a:p>
             <a:pPr algn="ctr"/>
+            <a:endParaRPr/>
           </a:p>
         </p:txBody>
       </p:sp>
@@ -11793,6 +11962,7 @@
           <a:lstStyle/>
           <a:p>
             <a:pPr algn="ctr"/>
+            <a:endParaRPr/>
           </a:p>
         </p:txBody>
       </p:sp>
@@ -11813,7 +11983,7 @@
           <a:noFill/>
         </p:spPr>
         <p:txBody>
-          <a:bodyPr wrap="square" lIns="76200" rIns="76200" tIns="50800" anchor="t">
+          <a:bodyPr wrap="square" lIns="76200" tIns="50800" rIns="76200" anchor="t">
             <a:spAutoFit/>
           </a:bodyPr>
           <a:lstStyle/>
@@ -11884,7 +12054,7 @@
           <a:noFill/>
         </p:spPr>
         <p:txBody>
-          <a:bodyPr wrap="square" lIns="76200" rIns="76200" tIns="50800" anchor="t">
+          <a:bodyPr wrap="square" lIns="76200" tIns="50800" rIns="76200" anchor="t">
             <a:spAutoFit/>
           </a:bodyPr>
           <a:lstStyle/>
@@ -11978,6 +12148,7 @@
           <a:lstStyle/>
           <a:p>
             <a:pPr algn="ctr"/>
+            <a:endParaRPr/>
           </a:p>
         </p:txBody>
       </p:sp>
@@ -12062,7 +12233,7 @@
 </file>
 
 <file path=ppt/slides/slide6.xml><?xml version="1.0" encoding="utf-8"?>
-<p:sld xmlns:a="http://schemas.openxmlformats.org/drawingml/2006/main" xmlns:p="http://schemas.openxmlformats.org/presentationml/2006/main" xmlns:r="http://schemas.openxmlformats.org/officeDocument/2006/relationships">
+<p:sld xmlns:a="http://schemas.openxmlformats.org/drawingml/2006/main" xmlns:r="http://schemas.openxmlformats.org/officeDocument/2006/relationships" xmlns:p="http://schemas.openxmlformats.org/presentationml/2006/main">
   <p:cSld>
     <p:bg>
       <p:bgPr>
@@ -12078,7 +12249,14 @@
         <p:cNvGrpSpPr/>
         <p:nvPr/>
       </p:nvGrpSpPr>
-      <p:grpSpPr/>
+      <p:grpSpPr>
+        <a:xfrm>
+          <a:off x="0" y="0"/>
+          <a:ext cx="0" cy="0"/>
+          <a:chOff x="0" y="0"/>
+          <a:chExt cx="0" cy="0"/>
+        </a:xfrm>
+      </p:grpSpPr>
       <p:sp>
         <p:nvSpPr>
           <p:cNvPr id="2" name="Rectangle 1"/>
@@ -12119,6 +12297,7 @@
           <a:lstStyle/>
           <a:p>
             <a:pPr algn="ctr"/>
+            <a:endParaRPr/>
           </a:p>
         </p:txBody>
       </p:sp>
@@ -12162,6 +12341,7 @@
           <a:lstStyle/>
           <a:p>
             <a:pPr algn="ctr"/>
+            <a:endParaRPr/>
           </a:p>
         </p:txBody>
       </p:sp>
@@ -12279,6 +12459,7 @@
           <a:lstStyle/>
           <a:p>
             <a:pPr algn="ctr"/>
+            <a:endParaRPr/>
           </a:p>
         </p:txBody>
       </p:sp>
@@ -12360,6 +12541,7 @@
           <a:lstStyle/>
           <a:p>
             <a:pPr algn="ctr"/>
+            <a:endParaRPr/>
           </a:p>
         </p:txBody>
       </p:sp>
@@ -12441,6 +12623,7 @@
           <a:lstStyle/>
           <a:p>
             <a:pPr algn="ctr"/>
+            <a:endParaRPr/>
           </a:p>
         </p:txBody>
       </p:sp>
@@ -12522,6 +12705,7 @@
           <a:lstStyle/>
           <a:p>
             <a:pPr algn="ctr"/>
+            <a:endParaRPr/>
           </a:p>
         </p:txBody>
       </p:sp>
@@ -12603,6 +12787,7 @@
           <a:lstStyle/>
           <a:p>
             <a:pPr algn="ctr"/>
+            <a:endParaRPr/>
           </a:p>
         </p:txBody>
       </p:sp>
@@ -12684,6 +12869,7 @@
           <a:lstStyle/>
           <a:p>
             <a:pPr algn="ctr"/>
+            <a:endParaRPr/>
           </a:p>
         </p:txBody>
       </p:sp>
@@ -12765,6 +12951,7 @@
           <a:lstStyle/>
           <a:p>
             <a:pPr algn="ctr"/>
+            <a:endParaRPr/>
           </a:p>
         </p:txBody>
       </p:sp>
@@ -12846,6 +13033,7 @@
           <a:lstStyle/>
           <a:p>
             <a:pPr algn="ctr"/>
+            <a:endParaRPr/>
           </a:p>
         </p:txBody>
       </p:sp>
@@ -12927,6 +13115,7 @@
           <a:lstStyle/>
           <a:p>
             <a:pPr algn="ctr"/>
+            <a:endParaRPr/>
           </a:p>
         </p:txBody>
       </p:sp>
@@ -13008,6 +13197,7 @@
           <a:lstStyle/>
           <a:p>
             <a:pPr algn="ctr"/>
+            <a:endParaRPr/>
           </a:p>
         </p:txBody>
       </p:sp>
@@ -13089,6 +13279,7 @@
           <a:lstStyle/>
           <a:p>
             <a:pPr algn="ctr"/>
+            <a:endParaRPr/>
           </a:p>
         </p:txBody>
       </p:sp>
@@ -13170,6 +13361,7 @@
           <a:lstStyle/>
           <a:p>
             <a:pPr algn="ctr"/>
+            <a:endParaRPr/>
           </a:p>
         </p:txBody>
       </p:sp>
@@ -13251,6 +13443,7 @@
           <a:lstStyle/>
           <a:p>
             <a:pPr algn="ctr"/>
+            <a:endParaRPr/>
           </a:p>
         </p:txBody>
       </p:sp>
@@ -13332,6 +13525,7 @@
           <a:lstStyle/>
           <a:p>
             <a:pPr algn="ctr"/>
+            <a:endParaRPr/>
           </a:p>
         </p:txBody>
       </p:sp>
@@ -13413,6 +13607,7 @@
           <a:lstStyle/>
           <a:p>
             <a:pPr algn="ctr"/>
+            <a:endParaRPr/>
           </a:p>
         </p:txBody>
       </p:sp>
@@ -13494,6 +13689,7 @@
           <a:lstStyle/>
           <a:p>
             <a:pPr algn="ctr"/>
+            <a:endParaRPr/>
           </a:p>
         </p:txBody>
       </p:sp>
@@ -13575,6 +13771,7 @@
           <a:lstStyle/>
           <a:p>
             <a:pPr algn="ctr"/>
+            <a:endParaRPr/>
           </a:p>
         </p:txBody>
       </p:sp>
@@ -13656,6 +13853,7 @@
           <a:lstStyle/>
           <a:p>
             <a:pPr algn="ctr"/>
+            <a:endParaRPr/>
           </a:p>
         </p:txBody>
       </p:sp>
@@ -13737,6 +13935,7 @@
           <a:lstStyle/>
           <a:p>
             <a:pPr algn="ctr"/>
+            <a:endParaRPr/>
           </a:p>
         </p:txBody>
       </p:sp>
@@ -13818,6 +14017,7 @@
           <a:lstStyle/>
           <a:p>
             <a:pPr algn="ctr"/>
+            <a:endParaRPr/>
           </a:p>
         </p:txBody>
       </p:sp>
@@ -13897,6 +14097,7 @@
           <a:lstStyle/>
           <a:p>
             <a:pPr algn="ctr"/>
+            <a:endParaRPr/>
           </a:p>
         </p:txBody>
       </p:sp>
@@ -13981,7 +14182,7 @@
 </file>
 
 <file path=ppt/slides/slide7.xml><?xml version="1.0" encoding="utf-8"?>
-<p:sld xmlns:a="http://schemas.openxmlformats.org/drawingml/2006/main" xmlns:p="http://schemas.openxmlformats.org/presentationml/2006/main" xmlns:r="http://schemas.openxmlformats.org/officeDocument/2006/relationships">
+<p:sld xmlns:a="http://schemas.openxmlformats.org/drawingml/2006/main" xmlns:r="http://schemas.openxmlformats.org/officeDocument/2006/relationships" xmlns:p="http://schemas.openxmlformats.org/presentationml/2006/main">
   <p:cSld>
     <p:bg>
       <p:bgPr>
@@ -13997,7 +14198,14 @@
         <p:cNvGrpSpPr/>
         <p:nvPr/>
       </p:nvGrpSpPr>
-      <p:grpSpPr/>
+      <p:grpSpPr>
+        <a:xfrm>
+          <a:off x="0" y="0"/>
+          <a:ext cx="0" cy="0"/>
+          <a:chOff x="0" y="0"/>
+          <a:chExt cx="0" cy="0"/>
+        </a:xfrm>
+      </p:grpSpPr>
       <p:sp>
         <p:nvSpPr>
           <p:cNvPr id="2" name="Rectangle 1"/>
@@ -14038,6 +14246,7 @@
           <a:lstStyle/>
           <a:p>
             <a:pPr algn="ctr"/>
+            <a:endParaRPr/>
           </a:p>
         </p:txBody>
       </p:sp>
@@ -14153,6 +14362,7 @@
           <a:lstStyle/>
           <a:p>
             <a:pPr algn="ctr"/>
+            <a:endParaRPr/>
           </a:p>
         </p:txBody>
       </p:sp>
@@ -14237,7 +14447,7 @@
 </file>
 
 <file path=ppt/slides/slide8.xml><?xml version="1.0" encoding="utf-8"?>
-<p:sld xmlns:a="http://schemas.openxmlformats.org/drawingml/2006/main" xmlns:p="http://schemas.openxmlformats.org/presentationml/2006/main" xmlns:r="http://schemas.openxmlformats.org/officeDocument/2006/relationships">
+<p:sld xmlns:a="http://schemas.openxmlformats.org/drawingml/2006/main" xmlns:r="http://schemas.openxmlformats.org/officeDocument/2006/relationships" xmlns:p="http://schemas.openxmlformats.org/presentationml/2006/main">
   <p:cSld>
     <p:bg>
       <p:bgPr>
@@ -14253,7 +14463,14 @@
         <p:cNvGrpSpPr/>
         <p:nvPr/>
       </p:nvGrpSpPr>
-      <p:grpSpPr/>
+      <p:grpSpPr>
+        <a:xfrm>
+          <a:off x="0" y="0"/>
+          <a:ext cx="0" cy="0"/>
+          <a:chOff x="0" y="0"/>
+          <a:chExt cx="0" cy="0"/>
+        </a:xfrm>
+      </p:grpSpPr>
       <p:sp>
         <p:nvSpPr>
           <p:cNvPr id="2" name="Rectangle 1"/>
@@ -14294,6 +14511,7 @@
           <a:lstStyle/>
           <a:p>
             <a:pPr algn="ctr"/>
+            <a:endParaRPr/>
           </a:p>
         </p:txBody>
       </p:sp>
@@ -14337,6 +14555,7 @@
           <a:lstStyle/>
           <a:p>
             <a:pPr algn="ctr"/>
+            <a:endParaRPr/>
           </a:p>
         </p:txBody>
       </p:sp>
@@ -14454,6 +14673,7 @@
           <a:lstStyle/>
           <a:p>
             <a:pPr algn="ctr"/>
+            <a:endParaRPr/>
           </a:p>
         </p:txBody>
       </p:sp>
@@ -14497,6 +14717,7 @@
           <a:lstStyle/>
           <a:p>
             <a:pPr algn="ctr"/>
+            <a:endParaRPr/>
           </a:p>
         </p:txBody>
       </p:sp>
@@ -14650,6 +14871,7 @@
           <a:lstStyle/>
           <a:p>
             <a:pPr algn="ctr"/>
+            <a:endParaRPr/>
           </a:p>
         </p:txBody>
       </p:sp>
@@ -14693,6 +14915,7 @@
           <a:lstStyle/>
           <a:p>
             <a:pPr algn="ctr"/>
+            <a:endParaRPr/>
           </a:p>
         </p:txBody>
       </p:sp>
@@ -14846,6 +15069,7 @@
           <a:lstStyle/>
           <a:p>
             <a:pPr algn="ctr"/>
+            <a:endParaRPr/>
           </a:p>
         </p:txBody>
       </p:sp>
@@ -14889,6 +15113,7 @@
           <a:lstStyle/>
           <a:p>
             <a:pPr algn="ctr"/>
+            <a:endParaRPr/>
           </a:p>
         </p:txBody>
       </p:sp>
@@ -15042,6 +15267,7 @@
           <a:lstStyle/>
           <a:p>
             <a:pPr algn="ctr"/>
+            <a:endParaRPr/>
           </a:p>
         </p:txBody>
       </p:sp>
@@ -15085,6 +15311,7 @@
           <a:lstStyle/>
           <a:p>
             <a:pPr algn="ctr"/>
+            <a:endParaRPr/>
           </a:p>
         </p:txBody>
       </p:sp>
@@ -15238,6 +15465,7 @@
           <a:lstStyle/>
           <a:p>
             <a:pPr algn="ctr"/>
+            <a:endParaRPr/>
           </a:p>
         </p:txBody>
       </p:sp>
@@ -15281,6 +15509,7 @@
           <a:lstStyle/>
           <a:p>
             <a:pPr algn="ctr"/>
+            <a:endParaRPr/>
           </a:p>
         </p:txBody>
       </p:sp>
@@ -15432,6 +15661,7 @@
           <a:lstStyle/>
           <a:p>
             <a:pPr algn="ctr"/>
+            <a:endParaRPr/>
           </a:p>
         </p:txBody>
       </p:sp>
@@ -15516,7 +15746,7 @@
 </file>
 
 <file path=ppt/slides/slide9.xml><?xml version="1.0" encoding="utf-8"?>
-<p:sld xmlns:a="http://schemas.openxmlformats.org/drawingml/2006/main" xmlns:p="http://schemas.openxmlformats.org/presentationml/2006/main" xmlns:r="http://schemas.openxmlformats.org/officeDocument/2006/relationships">
+<p:sld xmlns:a="http://schemas.openxmlformats.org/drawingml/2006/main" xmlns:r="http://schemas.openxmlformats.org/officeDocument/2006/relationships" xmlns:p="http://schemas.openxmlformats.org/presentationml/2006/main">
   <p:cSld>
     <p:bg>
       <p:bgPr>
@@ -15532,7 +15762,14 @@
         <p:cNvGrpSpPr/>
         <p:nvPr/>
       </p:nvGrpSpPr>
-      <p:grpSpPr/>
+      <p:grpSpPr>
+        <a:xfrm>
+          <a:off x="0" y="0"/>
+          <a:ext cx="0" cy="0"/>
+          <a:chOff x="0" y="0"/>
+          <a:chExt cx="0" cy="0"/>
+        </a:xfrm>
+      </p:grpSpPr>
       <p:sp>
         <p:nvSpPr>
           <p:cNvPr id="2" name="Rectangle 1"/>
@@ -15573,6 +15810,7 @@
           <a:lstStyle/>
           <a:p>
             <a:pPr algn="ctr"/>
+            <a:endParaRPr/>
           </a:p>
         </p:txBody>
       </p:sp>
@@ -15616,6 +15854,7 @@
           <a:lstStyle/>
           <a:p>
             <a:pPr algn="ctr"/>
+            <a:endParaRPr/>
           </a:p>
         </p:txBody>
       </p:sp>
@@ -15805,6 +16044,7 @@
           <a:lstStyle/>
           <a:p>
             <a:pPr algn="ctr"/>
+            <a:endParaRPr/>
           </a:p>
         </p:txBody>
       </p:sp>
@@ -15850,6 +16090,7 @@
           <a:lstStyle/>
           <a:p>
             <a:pPr algn="ctr"/>
+            <a:endParaRPr/>
           </a:p>
         </p:txBody>
       </p:sp>
@@ -15870,7 +16111,7 @@
           <a:noFill/>
         </p:spPr>
         <p:txBody>
-          <a:bodyPr wrap="square" lIns="76200" rIns="76200" tIns="50800" anchor="t">
+          <a:bodyPr wrap="square" lIns="76200" tIns="50800" rIns="76200" anchor="t">
             <a:spAutoFit/>
           </a:bodyPr>
           <a:lstStyle/>
@@ -15941,7 +16182,7 @@
           <a:noFill/>
         </p:spPr>
         <p:txBody>
-          <a:bodyPr wrap="square" lIns="76200" rIns="76200" tIns="50800" anchor="t">
+          <a:bodyPr wrap="square" lIns="76200" tIns="50800" rIns="76200" anchor="t">
             <a:spAutoFit/>
           </a:bodyPr>
           <a:lstStyle/>
@@ -16035,6 +16276,7 @@
           <a:lstStyle/>
           <a:p>
             <a:pPr algn="ctr"/>
+            <a:endParaRPr/>
           </a:p>
         </p:txBody>
       </p:sp>
@@ -16436,4 +16678,10 @@
   </a:objectDefaults>
   <a:extraClrSchemeLst/>
 </a:theme>
+</file>
+
+<file path=docMetadata/LabelInfo.xml><?xml version="1.0" encoding="utf-8"?>
+<clbl:labelList xmlns:clbl="http://schemas.microsoft.com/office/2020/mipLabelMetadata">
+  <clbl:label id="{f42aa342-8706-4288-bd11-ebb85995028c}" enabled="1" method="Standard" siteId="{72f988bf-86f1-41af-91ab-2d7cd011db47}" contentBits="0" removed="0"/>
+</clbl:labelList>
 </file>
</xml_diff>